<commit_message>
Disclose sample size on the hypothesis-reversal slide
The slide claimed the agent caught itself being wrong without stating
n=5 over one week, which SUBMISSION.md discloses plainly. Since the
slide's argument is that unflattering evidence gets surfaced, omitting
the caveat undercut it. Added as a visible band, plus speaker-note
guidance to say it out loud before a judge asks.
</commit_message>
<xml_diff>
--- a/finLM_CodeStreet2026.pptx
+++ b/finLM_CodeStreet2026.pptx
@@ -1598,7 +1598,7 @@
           <a:p>
             <a:r>
               <a:rPr lang="en-US" dirty="0"/>
-              <a:t>This is the slide that matters. The agent recorded a hypothesis, acted on it, and the scorer proved it wrong three days later. That reversal exists as a dated record instead of a forgotten assumption. No other agent framework produces this artifact.</a:t>
+              <a:t>This is the slide that matters. The agent recorded a hypothesis, acted on it, and the scorer proved it wrong three days later. Be first to say the sample size out loud: five decisions over one week, nowhere near statistically valid. The claim is not that the finding is conclusive — it is that the loop surfaced it automatically, dated and reviewable, without a human going looking. No other agent framework produces that artifact.</a:t>
             </a:r>
             <a:endParaRPr lang="en-US" dirty="0"/>
           </a:p>
@@ -8325,12 +8325,12 @@
         </p:nvSpPr>
         <p:spPr>
           <a:xfrm>
-            <a:off x="640080" y="1828800"/>
-            <a:ext cx="5212080" cy="2286000"/>
+            <a:off x="640080" y="1737360"/>
+            <a:ext cx="5212080" cy="2148840"/>
           </a:xfrm>
           <a:prstGeom prst="roundRect">
             <a:avLst>
-              <a:gd name="adj" fmla="val 4800"/>
+              <a:gd name="adj" fmla="val 5106"/>
             </a:avLst>
           </a:prstGeom>
           <a:solidFill>
@@ -8347,7 +8347,7 @@
         </p:nvSpPr>
         <p:spPr>
           <a:xfrm>
-            <a:off x="960120" y="2103120"/>
+            <a:off x="960120" y="1965960"/>
             <a:ext cx="4572000" cy="274320"/>
           </a:xfrm>
           <a:prstGeom prst="rect">
@@ -8386,7 +8386,7 @@
         </p:nvSpPr>
         <p:spPr>
           <a:xfrm>
-            <a:off x="960120" y="2468880"/>
+            <a:off x="960120" y="2304288"/>
             <a:ext cx="4572000" cy="1005840"/>
           </a:xfrm>
           <a:prstGeom prst="rect">
@@ -8428,8 +8428,8 @@
         </p:nvSpPr>
         <p:spPr>
           <a:xfrm>
-            <a:off x="960120" y="3520440"/>
-            <a:ext cx="4572000" cy="457200"/>
+            <a:off x="960120" y="3346704"/>
+            <a:ext cx="4572000" cy="411480"/>
           </a:xfrm>
           <a:prstGeom prst="rect">
             <a:avLst/>
@@ -8467,12 +8467,12 @@
         </p:nvSpPr>
         <p:spPr>
           <a:xfrm>
-            <a:off x="6355080" y="1828800"/>
-            <a:ext cx="5212080" cy="2286000"/>
+            <a:off x="6355080" y="1737360"/>
+            <a:ext cx="5212080" cy="2148840"/>
           </a:xfrm>
           <a:prstGeom prst="roundRect">
             <a:avLst>
-              <a:gd name="adj" fmla="val 4800"/>
+              <a:gd name="adj" fmla="val 5106"/>
             </a:avLst>
           </a:prstGeom>
           <a:solidFill>
@@ -8489,7 +8489,7 @@
         </p:nvSpPr>
         <p:spPr>
           <a:xfrm>
-            <a:off x="6675120" y="2103120"/>
+            <a:off x="6675120" y="1965960"/>
             <a:ext cx="4572000" cy="274320"/>
           </a:xfrm>
           <a:prstGeom prst="rect">
@@ -8528,7 +8528,7 @@
         </p:nvSpPr>
         <p:spPr>
           <a:xfrm>
-            <a:off x="6675120" y="2468880"/>
+            <a:off x="6675120" y="2304288"/>
             <a:ext cx="4572000" cy="411480"/>
           </a:xfrm>
           <a:prstGeom prst="rect">
@@ -8567,8 +8567,8 @@
         </p:nvSpPr>
         <p:spPr>
           <a:xfrm>
-            <a:off x="6675120" y="2971800"/>
-            <a:ext cx="4572000" cy="1005840"/>
+            <a:off x="6675120" y="2788920"/>
+            <a:ext cx="4572000" cy="960120"/>
           </a:xfrm>
           <a:prstGeom prst="rect">
             <a:avLst/>
@@ -8603,13 +8603,88 @@
       </p:sp>
       <p:sp>
         <p:nvSpPr>
-          <p:cNvPr id="12" name="Text 10"/>
-          <p:cNvSpPr/>
-          <p:nvPr/>
-        </p:nvSpPr>
-        <p:spPr>
-          <a:xfrm>
-            <a:off x="640080" y="4526280"/>
+          <p:cNvPr id="12" name="Shape 10"/>
+          <p:cNvSpPr/>
+          <p:nvPr/>
+        </p:nvSpPr>
+        <p:spPr>
+          <a:xfrm>
+            <a:off x="640080" y="4041648"/>
+            <a:ext cx="10908792" cy="566928"/>
+          </a:xfrm>
+          <a:prstGeom prst="roundRect">
+            <a:avLst>
+              <a:gd name="adj" fmla="val 19355"/>
+            </a:avLst>
+          </a:prstGeom>
+          <a:solidFill>
+            <a:srgbClr val="16274A"/>
+          </a:solidFill>
+          <a:ln/>
+        </p:spPr>
+      </p:sp>
+      <p:sp>
+        <p:nvSpPr>
+          <p:cNvPr id="13" name="Text 11"/>
+          <p:cNvSpPr/>
+          <p:nvPr/>
+        </p:nvSpPr>
+        <p:spPr>
+          <a:xfrm>
+            <a:off x="960120" y="4041648"/>
+            <a:ext cx="10287000" cy="566928"/>
+          </a:xfrm>
+          <a:prstGeom prst="rect">
+            <a:avLst/>
+          </a:prstGeom>
+          <a:noFill/>
+          <a:ln/>
+        </p:spPr>
+        <p:txBody>
+          <a:bodyPr wrap="square" lIns="0" tIns="0" rIns="0" bIns="0" rtlCol="0" anchor="ctr"/>
+          <a:lstStyle/>
+          <a:p>
+            <a:pPr indent="0" marL="0">
+              <a:buNone/>
+            </a:pPr>
+            <a:r>
+              <a:rPr lang="en-US" sz="1300" b="1" dirty="0">
+                <a:solidFill>
+                  <a:srgbClr val="2ED8A7"/>
+                </a:solidFill>
+                <a:latin typeface="Calibri" pitchFamily="34" charset="0"/>
+                <a:ea typeface="Calibri" pitchFamily="34" charset="-122"/>
+                <a:cs typeface="Calibri" pitchFamily="34" charset="-120"/>
+              </a:rPr>
+              <a:t>n = 5, one week. </a:t>
+            </a:r>
+            <a:pPr indent="0" marL="0">
+              <a:buNone/>
+            </a:pPr>
+            <a:r>
+              <a:rPr lang="en-US" sz="1300" dirty="0">
+                <a:solidFill>
+                  <a:srgbClr val="AFC3E0"/>
+                </a:solidFill>
+                <a:latin typeface="Calibri" pitchFamily="34" charset="0"/>
+                <a:ea typeface="Calibri" pitchFamily="34" charset="-122"/>
+                <a:cs typeface="Calibri" pitchFamily="34" charset="-120"/>
+              </a:rPr>
+              <a:t>Not statistically valid — and logged, dated and testable anyway. That is the point: the loop caught it, not a person reviewing it later.</a:t>
+            </a:r>
+            <a:endParaRPr lang="en-US" sz="1300" dirty="0"/>
+          </a:p>
+        </p:txBody>
+      </p:sp>
+      <p:sp>
+        <p:nvSpPr>
+          <p:cNvPr id="14" name="Text 12"/>
+          <p:cNvSpPr/>
+          <p:nvPr/>
+        </p:nvSpPr>
+        <p:spPr>
+          <a:xfrm>
+            <a:off x="640080" y="4800600"/>
             <a:ext cx="10881360" cy="914400"/>
           </a:xfrm>
           <a:prstGeom prst="rect">
@@ -8665,13 +8740,13 @@
       </p:sp>
       <p:sp>
         <p:nvSpPr>
-          <p:cNvPr id="13" name="Text 11"/>
-          <p:cNvSpPr/>
-          <p:nvPr/>
-        </p:nvSpPr>
-        <p:spPr>
-          <a:xfrm>
-            <a:off x="640080" y="5577840"/>
+          <p:cNvPr id="15" name="Text 13"/>
+          <p:cNvSpPr/>
+          <p:nvPr/>
+        </p:nvSpPr>
+        <p:spPr>
+          <a:xfrm>
+            <a:off x="640080" y="5852160"/>
             <a:ext cx="10881360" cy="457200"/>
           </a:xfrm>
           <a:prstGeom prst="rect">

</xml_diff>

<commit_message>
Set deck author and byline to Hasil
</commit_message>
<xml_diff>
--- a/finLM_CodeStreet2026.pptx
+++ b/finLM_CodeStreet2026.pptx
@@ -806,7 +806,7 @@
           <a:p>
             <a:r>
               <a:rPr lang="en-US" dirty="0"/>
-              <a:t>finLM is a governance layer for financial agents. Everyone is shipping agents that can move money. Nobody is shipping the layer that makes them safe to deploy and auditable afterwards. We built that layer, and we proved it by putting a real financial agent inside it.</a:t>
+              <a:t>finLM is a governance layer for financial agents. Everyone is shipping agents that can move money. Nobody is shipping the layer that makes them safe to deploy and auditable afterwards. We built that layer and put a market-analysis agent inside it, scored against real NSE closing prices. Be first to say this: the decisions are paper decisions. No order was ever placed, because the mandate file authorising one was never written — the gate refused every time. That is the design demonstrating itself.</a:t>
             </a:r>
             <a:endParaRPr lang="en-US" dirty="0"/>
           </a:p>
@@ -1510,7 +1510,7 @@
           <a:p>
             <a:r>
               <a:rPr lang="en-US" dirty="0"/>
-              <a:t>We did not just describe a governance layer. We built one and put a real financial agent inside it. Pre-deployment validation showed the intuitive strategy loses in every configuration, and validated the counterintuitive one. Live, the top decision returned 10.31 percent against a falling market.</a:t>
+              <a:t>We did not just describe a governance layer. We built one and put a market-analysis agent inside it. Pre-deployment validation showed the intuitive strategy loses in every configuration, and validated the counterintuitive one. The top paper decision returned 10.31 percent against a falling market. Say the disclosure out loud before anyone asks: these are paper decisions scored against real closing prices. No order was ever placed, because the mandate file authorising one was never written — the gate refused every time. That is the thesis demonstrating itself, not a missing feature.</a:t>
             </a:r>
             <a:endParaRPr lang="en-US" dirty="0"/>
           </a:p>
@@ -1598,7 +1598,7 @@
           <a:p>
             <a:r>
               <a:rPr lang="en-US" dirty="0"/>
-              <a:t>This is the slide that matters. The agent recorded a hypothesis, acted on it, and the scorer proved it wrong three days later. Be first to say the sample size out loud: five decisions over one week, nowhere near statistically valid. The claim is not that the finding is conclusive — it is that the loop surfaced it automatically, dated and reviewable, without a human going looking. Then land the escalation: the same discipline caught a backtest number that would not reproduce (fixed with a provenance layer), and finally caught a regime hypothesis we had pre-registered — prediction interval and falsification region written down BEFORE the data was computed, and the observation landed outside it. The third one is the punchline: anyone can explain a result after the fact; almost nobody sets up a test they can lose. Artifacts for all three are in artifacts/ and cited in CLAUDE.md.</a:t>
+              <a:t>This is the slide that matters. The agent recorded a hypothesis, acted on it, and the scorer proved it wrong three days later. Be first to say the sample size out loud: five decisions over one week, nowhere near statistically valid. The claim is not that the finding is conclusive — it is that the loop surfaced it automatically, dated and reviewable, without a human going looking. Then land the escalation: the same discipline caught a backtest number that would not reproduce (fixed with a provenance layer), and finally caught a regime hypothesis we had pre-registered — prediction interval and falsification region written down BEFORE the data was computed, and the observation landed outside it. The third one is the punchline: anyone can explain a result after the fact; almost nobody sets up a test they can lose. Artifacts for all three are in artifacts/ and cited in the README.</a:t>
             </a:r>
             <a:endParaRPr lang="en-US" dirty="0"/>
           </a:p>
@@ -2272,7 +2272,7 @@
                 <a:ea typeface="Calibri" pitchFamily="34" charset="-122"/>
                 <a:cs typeface="Calibri" pitchFamily="34" charset="-120"/>
               </a:rPr>
-              <a:t>Proven by governing a real financial agent against live markets.</a:t>
+              <a:t>Scored against real NSE prices. Paper decisions only — no order was ever placed.</a:t>
             </a:r>
             <a:endParaRPr lang="en-US" sz="1500" dirty="0"/>
           </a:p>
@@ -2372,7 +2372,7 @@
                 <a:ea typeface="Calibri" pitchFamily="34" charset="-122"/>
                 <a:cs typeface="Calibri" pitchFamily="34" charset="-120"/>
               </a:rPr>
-              <a:t>Anish Naik  ·  Idea Submission</a:t>
+              <a:t>Hasil  ·  Idea Submission</a:t>
             </a:r>
             <a:endParaRPr lang="en-US" sz="1200" dirty="0"/>
           </a:p>
@@ -2580,7 +2580,7 @@
                 <a:ea typeface="Calibri" pitchFamily="34" charset="-122"/>
                 <a:cs typeface="Calibri" pitchFamily="34" charset="-120"/>
               </a:rPr>
-              <a:t>13 MCP tools live and verified over the protocol, in Claude Desktop and Claude Code</a:t>
+              <a:t>15 MCP tools live and verified over the protocol, across desktop and CLI MCP clients</a:t>
             </a:r>
             <a:endParaRPr lang="en-US" sz="1350" dirty="0"/>
           </a:p>
@@ -3780,7 +3780,7 @@
                 <a:ea typeface="Cambria" pitchFamily="34" charset="-122"/>
                 <a:cs typeface="Cambria" pitchFamily="34" charset="-120"/>
               </a:rPr>
-              <a:t>finLM  ·  Anish Naik  ·  CodeStreet 2026</a:t>
+              <a:t>finLM  ·  Hasil  ·  CodeStreet 2026</a:t>
             </a:r>
             <a:endParaRPr lang="en-US" sz="1500" dirty="0"/>
           </a:p>
@@ -6684,7 +6684,7 @@
                 <a:ea typeface="Calibri" pitchFamily="34" charset="-122"/>
                 <a:cs typeface="Calibri" pitchFamily="34" charset="-120"/>
               </a:rPr>
-              <a:t>Claude · GPT · Gemini</a:t>
+              <a:t>Any MCP client</a:t>
             </a:r>
             <a:endParaRPr lang="en-US" sz="1200" dirty="0"/>
           </a:p>

</xml_diff>

<commit_message>
Replace typographic dashes and quotes with plain ASCII
</commit_message>
<xml_diff>
--- a/finLM_CodeStreet2026.pptx
+++ b/finLM_CodeStreet2026.pptx
@@ -806,7 +806,7 @@
           <a:p>
             <a:r>
               <a:rPr lang="en-US" dirty="0"/>
-              <a:t>finLM is a governance layer for financial agents. Everyone is shipping agents that can move money. Nobody is shipping the layer that makes them safe to deploy and auditable afterwards. We built that layer and put a market-analysis agent inside it, scored against real NSE closing prices. Be first to say this: the decisions are paper decisions. No order was ever placed, because the mandate file authorising one was never written — the gate refused every time. That is the design demonstrating itself.</a:t>
+              <a:t>finLM is a governance layer for financial agents. Everyone is shipping agents that can move money. Nobody is shipping the layer that makes them safe to deploy and auditable afterwards. We built that layer and put a market-analysis agent inside it, scored against real NSE closing prices. Be first to say this: the decisions are paper decisions. No order was ever placed, because the mandate file authorising one was never written - the gate refused every time. That is the design demonstrating itself.</a:t>
             </a:r>
             <a:endParaRPr lang="en-US" dirty="0"/>
           </a:p>
@@ -1158,7 +1158,7 @@
           <a:p>
             <a:r>
               <a:rPr lang="en-US" dirty="0"/>
-              <a:t>These are the questions a risk officer, a regulator, or an incident review will ask. Today's financial agents cannot answer any of them. That is the real blocker to deploying agents in a regulated institution — not model capability.</a:t>
+              <a:t>These are the questions a risk officer, a regulator, or an incident review will ask. Today's financial agents cannot answer any of them. That is the real blocker to deploying agents in a regulated institution - not model capability.</a:t>
             </a:r>
             <a:endParaRPr lang="en-US" dirty="0"/>
           </a:p>
@@ -1510,7 +1510,7 @@
           <a:p>
             <a:r>
               <a:rPr lang="en-US" dirty="0"/>
-              <a:t>We did not just describe a governance layer. We built one and put a market-analysis agent inside it. Pre-deployment validation showed the intuitive strategy loses in every configuration, and validated the counterintuitive one. The top paper decision returned 10.31 percent against a falling market. Say the disclosure out loud before anyone asks: these are paper decisions scored against real closing prices. No order was ever placed, because the mandate file authorising one was never written — the gate refused every time. That is the thesis demonstrating itself, not a missing feature.</a:t>
+              <a:t>We did not just describe a governance layer. We built one and put a market-analysis agent inside it. Pre-deployment validation showed the intuitive strategy loses in every configuration, and validated the counterintuitive one. The top paper decision returned 10.31 percent against a falling market. Say the disclosure out loud before anyone asks: these are paper decisions scored against real closing prices. No order was ever placed, because the mandate file authorising one was never written - the gate refused every time. That is the thesis demonstrating itself, not a missing feature.</a:t>
             </a:r>
             <a:endParaRPr lang="en-US" dirty="0"/>
           </a:p>
@@ -1598,7 +1598,7 @@
           <a:p>
             <a:r>
               <a:rPr lang="en-US" dirty="0"/>
-              <a:t>This is the slide that matters. The agent recorded a hypothesis, acted on it, and the scorer proved it wrong three days later. Be first to say the sample size out loud: five decisions over one week, nowhere near statistically valid. The claim is not that the finding is conclusive — it is that the loop surfaced it automatically, dated and reviewable, without a human going looking. Then land the escalation: the same discipline caught a backtest number that would not reproduce (fixed with a provenance layer), and finally caught a regime hypothesis we had pre-registered — prediction interval and falsification region written down BEFORE the data was computed, and the observation landed outside it. The third one is the punchline: anyone can explain a result after the fact; almost nobody sets up a test they can lose. Artifacts for all three are in artifacts/ and cited in the README.</a:t>
+              <a:t>This is the slide that matters. The agent recorded a hypothesis, acted on it, and the scorer proved it wrong three days later. Be first to say the sample size out loud: five decisions over one week, nowhere near statistically valid. The claim is not that the finding is conclusive - it is that the loop surfaced it automatically, dated and reviewable, without a human going looking. Then land the escalation: the same discipline caught a backtest number that would not reproduce (fixed with a provenance layer), and finally caught a regime hypothesis we had pre-registered - prediction interval and falsification region written down BEFORE the data was computed, and the observation landed outside it. The third one is the punchline: anyone can explain a result after the fact; almost nobody sets up a test they can lose. Artifacts for all three are in artifacts/ and cited in the README.</a:t>
             </a:r>
             <a:endParaRPr lang="en-US" dirty="0"/>
           </a:p>
@@ -1686,7 +1686,7 @@
           <a:p>
             <a:r>
               <a:rPr lang="en-US" dirty="0"/>
-              <a:t>The primitives are domain-agnostic. A dispute agent, a benefit activation agent, a servicing agent — each needs the same four things. Only the action schema and the outcome scorer change per domain.</a:t>
+              <a:t>The primitives are domain-agnostic. A dispute agent, a benefit activation agent, a servicing agent - each needs the same four things. Only the action schema and the outcome scorer change per domain.</a:t>
             </a:r>
             <a:endParaRPr lang="en-US" dirty="0"/>
           </a:p>
@@ -2272,7 +2272,7 @@
                 <a:ea typeface="Calibri" pitchFamily="34" charset="-122"/>
                 <a:cs typeface="Calibri" pitchFamily="34" charset="-120"/>
               </a:rPr>
-              <a:t>Scored against real NSE prices. Paper decisions only — no order was ever placed.</a:t>
+              <a:t>Scored against real NSE prices. Paper decisions only - no order was ever placed.</a:t>
             </a:r>
             <a:endParaRPr lang="en-US" sz="1500" dirty="0"/>
           </a:p>
@@ -2678,7 +2678,7 @@
                 <a:ea typeface="Calibri" pitchFamily="34" charset="-122"/>
                 <a:cs typeface="Calibri" pitchFamily="34" charset="-120"/>
               </a:rPr>
-              <a:t>Mandate gate and kill switch enforced server-side — tested, and they fail closed</a:t>
+              <a:t>Mandate gate and kill switch enforced server-side - tested, and they fail closed</a:t>
             </a:r>
             <a:endParaRPr lang="en-US" sz="1350" dirty="0"/>
           </a:p>
@@ -3098,7 +3098,7 @@
                 <a:ea typeface="Calibri" pitchFamily="34" charset="-122"/>
                 <a:cs typeface="Calibri" pitchFamily="34" charset="-120"/>
               </a:rPr>
-              <a:t>NEXT — PROTOTYPE ROUND</a:t>
+              <a:t>NEXT - PROTOTYPE ROUND</a:t>
             </a:r>
             <a:endParaRPr lang="en-US" sz="1100" dirty="0"/>
           </a:p>
@@ -3497,7 +3497,7 @@
                 <a:ea typeface="Calibri" pitchFamily="34" charset="-122"/>
                 <a:cs typeface="Calibri" pitchFamily="34" charset="-120"/>
               </a:rPr>
-              <a:t>finLM makes an agent's authority enforceable, its reasoning auditable, and its judgment measurable — so a financial institution can actually deploy one.</a:t>
+              <a:t>finLM makes an agent's authority enforceable, its reasoning auditable, and its judgment measurable - so a financial institution can actually deploy one.</a:t>
             </a:r>
             <a:endParaRPr lang="en-US" sz="1600" dirty="0"/>
           </a:p>
@@ -4212,7 +4212,7 @@
                 <a:ea typeface="Calibri" pitchFamily="34" charset="-122"/>
                 <a:cs typeface="Calibri" pitchFamily="34" charset="-120"/>
               </a:rPr>
-              <a:t>Guardrails live in prompts — </a:t>
+              <a:t>Guardrails live in prompts - </a:t>
             </a:r>
             <a:pPr indent="0" marL="0">
               <a:buNone/>
@@ -4324,7 +4324,7 @@
                 <a:ea typeface="Calibri" pitchFamily="34" charset="-122"/>
                 <a:cs typeface="Calibri" pitchFamily="34" charset="-120"/>
               </a:rPr>
-              <a:t>No record of intent — </a:t>
+              <a:t>No record of intent - </a:t>
             </a:r>
             <a:pPr indent="0" marL="0">
               <a:buNone/>
@@ -4436,7 +4436,7 @@
                 <a:ea typeface="Calibri" pitchFamily="34" charset="-122"/>
                 <a:cs typeface="Calibri" pitchFamily="34" charset="-120"/>
               </a:rPr>
-              <a:t>No measure of quality — </a:t>
+              <a:t>No measure of quality - </a:t>
             </a:r>
             <a:pPr indent="0" marL="0">
               <a:buNone/>
@@ -4884,7 +4884,7 @@
                 <a:ea typeface="Calibri" pitchFamily="34" charset="-122"/>
                 <a:cs typeface="Calibri" pitchFamily="34" charset="-120"/>
               </a:rPr>
-              <a:t>Reasoning is reconstructed after the fact, if it survives at all — not captured at decision time.</a:t>
+              <a:t>Reasoning is reconstructed after the fact, if it survives at all - not captured at decision time.</a:t>
             </a:r>
             <a:endParaRPr lang="en-US" sz="1300" dirty="0"/>
           </a:p>
@@ -5085,7 +5085,7 @@
                 <a:ea typeface="Cambria" pitchFamily="34" charset="-122"/>
                 <a:cs typeface="Cambria" pitchFamily="34" charset="-120"/>
               </a:rPr>
-              <a:t>In a regulated institution, an agent that cannot be audited cannot be deployed — no matter how good it is.</a:t>
+              <a:t>In a regulated institution, an agent that cannot be audited cannot be deployed - no matter how good it is.</a:t>
             </a:r>
             <a:endParaRPr lang="en-US" sz="1900" dirty="0"/>
           </a:p>
@@ -5674,7 +5674,7 @@
                 <a:ea typeface="Calibri" pitchFamily="34" charset="-122"/>
                 <a:cs typeface="Calibri" pitchFamily="34" charset="-120"/>
               </a:rPr>
-              <a:t>Capability and authority are separated by construction — the model can call the checks, never modify them.</a:t>
+              <a:t>Capability and authority are separated by construction - the model can call the checks, never modify them.</a:t>
             </a:r>
             <a:endParaRPr lang="en-US" sz="1400" dirty="0"/>
           </a:p>
@@ -5946,7 +5946,7 @@
                 <a:ea typeface="Calibri" pitchFamily="34" charset="-122"/>
                 <a:cs typeface="Calibri" pitchFamily="34" charset="-120"/>
               </a:rPr>
-              <a:t>Every consequential action is validated against a policy file the user writes outside the conversation — value caps, action limits, allowlists. Fails closed: no mandate, nothing executes.</a:t>
+              <a:t>Every consequential action is validated against a policy file the user writes outside the conversation - value caps, action limits, allowlists. Fails closed: no mandate, nothing executes.</a:t>
             </a:r>
             <a:endParaRPr lang="en-US" sz="1250" dirty="0"/>
           </a:p>
@@ -6108,7 +6108,7 @@
                 <a:ea typeface="Calibri" pitchFamily="34" charset="-122"/>
                 <a:cs typeface="Calibri" pitchFamily="34" charset="-120"/>
               </a:rPr>
-              <a:t>A filesystem circuit breaker. Drop the file and every action is refused instantly — no restart, no config reload, no cooperation from the agent required.</a:t>
+              <a:t>A filesystem circuit breaker. Drop the file and every action is refused instantly - no restart, no config reload, no cooperation from the agent required.</a:t>
             </a:r>
             <a:endParaRPr lang="en-US" sz="1250" dirty="0"/>
           </a:p>
@@ -6270,7 +6270,7 @@
                 <a:ea typeface="Calibri" pitchFamily="34" charset="-122"/>
                 <a:cs typeface="Calibri" pitchFamily="34" charset="-120"/>
               </a:rPr>
-              <a:t>Every decision journaled the moment it is made, with the agent's full thesis captured verbatim — reviewable months later, not reconstructed.</a:t>
+              <a:t>Every decision journaled the moment it is made, with the agent's full thesis captured verbatim - reviewable months later, not reconstructed.</a:t>
             </a:r>
             <a:endParaRPr lang="en-US" sz="1250" dirty="0"/>
           </a:p>
@@ -7648,7 +7648,7 @@
                 <a:ea typeface="Calibri" pitchFamily="34" charset="-122"/>
                 <a:cs typeface="Calibri" pitchFamily="34" charset="-120"/>
               </a:rPr>
-              <a:t>Afterwards the scorer grades every journaled decision against what actually happened — closing the loop no agent framework closes today.</a:t>
+              <a:t>Afterwards the scorer grades every journaled decision against what actually happened - closing the loop no agent framework closes today.</a:t>
             </a:r>
             <a:endParaRPr lang="en-US" sz="1350" dirty="0"/>
           </a:p>
@@ -7719,7 +7719,7 @@
                 <a:ea typeface="Calibri" pitchFamily="34" charset="-122"/>
                 <a:cs typeface="Calibri" pitchFamily="34" charset="-120"/>
               </a:rPr>
-              <a:t>PROOF — WE ALREADY BUILT AND RAN IT</a:t>
+              <a:t>PROOF - WE ALREADY BUILT AND RAN IT</a:t>
             </a:r>
             <a:endParaRPr lang="en-US" sz="1200" dirty="0"/>
           </a:p>
@@ -7839,7 +7839,7 @@
                 <a:ea typeface="Calibri" pitchFamily="34" charset="-122"/>
                 <a:cs typeface="Calibri" pitchFamily="34" charset="-120"/>
               </a:rPr>
-              <a:t>years 2010-2020 with positive net-of-cost alpha, 8,405 trades — sign test p = 0.0005</a:t>
+              <a:t>years 2010-2020 with positive net-of-cost alpha, 8,405 trades - sign test p = 0.0005</a:t>
             </a:r>
             <a:endParaRPr lang="en-US" sz="1250" dirty="0"/>
           </a:p>
@@ -7920,7 +7920,7 @@
                 <a:ea typeface="Calibri" pitchFamily="34" charset="-122"/>
                 <a:cs typeface="Calibri" pitchFamily="34" charset="-120"/>
               </a:rPr>
-              <a:t>per trade: the intuitive 'chase momentum' policy, net of costs — negative in every configuration</a:t>
+              <a:t>per trade: the intuitive 'chase momentum' policy, net of costs - negative in every configuration</a:t>
             </a:r>
             <a:endParaRPr lang="en-US" sz="1250" dirty="0"/>
           </a:p>
@@ -8414,7 +8414,7 @@
                 <a:ea typeface="Cambria" pitchFamily="34" charset="-122"/>
                 <a:cs typeface="Cambria" pitchFamily="34" charset="-120"/>
               </a:rPr>
-              <a:t>“Moves backed by a genuine news catalyst behave differently, so we take no action on those.”</a:t>
+              <a:t>"Moves backed by a genuine news catalyst behave differently, so we take no action on those."</a:t>
             </a:r>
             <a:endParaRPr lang="en-US" sz="1600" dirty="0"/>
           </a:p>
@@ -8595,7 +8595,7 @@
                 <a:ea typeface="Calibri" pitchFamily="34" charset="-122"/>
                 <a:cs typeface="Calibri" pitchFamily="34" charset="-120"/>
               </a:rPr>
-              <a:t>Catalyst-backed moves reversed just as hard. The agent's own reasoning cost it two profitable decisions — and the data said so within three days.</a:t>
+              <a:t>Catalyst-backed moves reversed just as hard. The agent's own reasoning cost it two profitable decisions - and the data said so within three days.</a:t>
             </a:r>
             <a:endParaRPr lang="en-US" sz="1300" dirty="0"/>
           </a:p>
@@ -8670,7 +8670,7 @@
                 <a:ea typeface="Calibri" pitchFamily="34" charset="-122"/>
                 <a:cs typeface="Calibri" pitchFamily="34" charset="-120"/>
               </a:rPr>
-              <a:t>Not statistically valid — and logged, dated and testable anyway. That is the point: the loop caught it, not a person reviewing it later.</a:t>
+              <a:t>Not statistically valid - and logged, dated and testable anyway. That is the point: the loop caught it, not a person reviewing it later.</a:t>
             </a:r>
             <a:endParaRPr lang="en-US" sz="1300" dirty="0"/>
           </a:p>
@@ -8709,7 +8709,7 @@
                 <a:ea typeface="Calibri" pitchFamily="34" charset="-122"/>
                 <a:cs typeface="Calibri" pitchFamily="34" charset="-120"/>
               </a:rPr>
-              <a:t>AND IT KEPT HAPPENING — THREE TIMES, ESCALATING</a:t>
+              <a:t>AND IT KEPT HAPPENING - THREE TIMES, ESCALATING</a:t>
             </a:r>
             <a:endParaRPr lang="en-US" sz="1100" dirty="0"/>
           </a:p>
@@ -8751,7 +8751,7 @@
                 <a:ea typeface="Calibri" pitchFamily="34" charset="-122"/>
                 <a:cs typeface="Calibri" pitchFamily="34" charset="-120"/>
               </a:rPr>
-              <a:t>Caught after the fact — </a:t>
+              <a:t>Caught after the fact - </a:t>
             </a:r>
             <a:pPr indent="0" marL="0">
               <a:lnSpc>
@@ -8810,7 +8810,7 @@
                 <a:ea typeface="Calibri" pitchFamily="34" charset="-122"/>
                 <a:cs typeface="Calibri" pitchFamily="34" charset="-120"/>
               </a:rPr>
-              <a:t>Caught by audit — </a:t>
+              <a:t>Caught by audit - </a:t>
             </a:r>
             <a:pPr indent="0" marL="0">
               <a:lnSpc>
@@ -8869,7 +8869,7 @@
                 <a:ea typeface="Calibri" pitchFamily="34" charset="-122"/>
                 <a:cs typeface="Calibri" pitchFamily="34" charset="-120"/>
               </a:rPr>
-              <a:t>Caught in advance — </a:t>
+              <a:t>Caught in advance - </a:t>
             </a:r>
             <a:pPr indent="0" marL="0">
               <a:lnSpc>
@@ -9035,7 +9035,7 @@
                 <a:ea typeface="Cambria" pitchFamily="34" charset="-122"/>
                 <a:cs typeface="Cambria" pitchFamily="34" charset="-120"/>
               </a:rPr>
-              <a:t>Swap the action schema and the scorer — the layer holds</a:t>
+              <a:t>Swap the action schema and the scorer - the layer holds</a:t>
             </a:r>
             <a:endParaRPr lang="en-US" sz="3400" dirty="0"/>
           </a:p>
@@ -9551,7 +9551,7 @@
                 <a:ea typeface="Cambria" pitchFamily="34" charset="-122"/>
                 <a:cs typeface="Cambria" pitchFamily="34" charset="-120"/>
               </a:rPr>
-              <a:t>The audit trail, the kill switch and the fail-closed mandate never change. Only the action schema and the definition of “was it right” do.</a:t>
+              <a:t>The audit trail, the kill switch and the fail-closed mandate never change. Only the action schema and the definition of "was it right" do.</a:t>
             </a:r>
             <a:endParaRPr lang="en-US" sz="1700" dirty="0"/>
           </a:p>

</xml_diff>